<commit_message>
Reorder app slides 01-11 in numerical sequence
App #9 was previously placed after #5 (left over from when it was a
Tier-3 app among Tier-1/2 implementations). All 11 app slides now
appear in numerical order across slides 5-15 of the deck.
</commit_message>
<xml_diff>
--- a/_pitch-deck/BTP-Advisory-Pitch.pptx
+++ b/_pitch-deck/BTP-Advisory-Pitch.pptx
@@ -2913,7 +2913,7 @@
                 <a:ea typeface="Georgia" pitchFamily="34" charset="-122"/>
                 <a:cs typeface="Georgia" pitchFamily="34" charset="-120"/>
               </a:rPr>
-              <a:t>APP 09</a:t>
+              <a:t>APP 06</a:t>
             </a:r>
             <a:endParaRPr lang="en-US" sz="1400" dirty="0"/>
           </a:p>
@@ -2952,7 +2952,7 @@
                 <a:ea typeface="Calibri" pitchFamily="34" charset="-122"/>
                 <a:cs typeface="Calibri" pitchFamily="34" charset="-120"/>
               </a:rPr>
-              <a:t>TIER 3 · INCIDENT PREVENTION · IMPLEMENTED</a:t>
+              <a:t>TIER 2 · COMPLIANCE-DRIVEN ENGAGEMENTS · IMPLEMENTED</a:t>
             </a:r>
             <a:endParaRPr lang="en-US" sz="1000" dirty="0"/>
           </a:p>
@@ -2991,7 +2991,7 @@
                 <a:ea typeface="Georgia" pitchFamily="34" charset="-122"/>
                 <a:cs typeface="Georgia" pitchFamily="34" charset="-120"/>
               </a:rPr>
-              <a:t>Trust Config &amp; Cert Expiry Console</a:t>
+              <a:t>Audit-Log &amp; Change Inventory Console</a:t>
             </a:r>
             <a:endParaRPr lang="en-US" sz="1800" dirty="0"/>
           </a:p>
@@ -3019,7 +3019,7 @@
       </p:sp>
       <p:pic>
         <p:nvPicPr>
-          <p:cNvPr id="8" name="Image 0" descr="D:\Claude\BTP Advisory APps\_pitch-deck\screenshots\app09-certs.png">    </p:cNvPr>
+          <p:cNvPr id="8" name="Image 0" descr="D:\Claude\BTP Advisory APps\_pitch-deck\screenshots\app06-auditlog.png">    </p:cNvPr>
           <p:cNvPicPr>
             <a:picLocks noChangeAspect="1"/>
           </p:cNvPicPr>
@@ -3073,7 +3073,7 @@
                 <a:ea typeface="Georgia" pitchFamily="34" charset="-122"/>
                 <a:cs typeface="Georgia" pitchFamily="34" charset="-120"/>
               </a:rPr>
-              <a:t>Every certificate across the BTP landscape with rotation owner, blast radius, and acknowledgement workflow.</a:t>
+              <a:t>Unified change timeline across subaccounts. The deliverable a SOX walkthrough is built around.</a:t>
             </a:r>
             <a:endParaRPr lang="en-US" sz="1700" dirty="0"/>
           </a:p>
@@ -3155,7 +3155,7 @@
                 <a:ea typeface="Calibri" pitchFamily="34" charset="-122"/>
                 <a:cs typeface="Calibri" pitchFamily="34" charset="-120"/>
               </a:rPr>
-              <a:t>Aggregates from destinations, IAS SAML/OIDC, XSUAA trust configs, cTMS keys.</a:t>
+              <a:t>Aggregates Audit Log Retrieval Service + cTMS deployment history + Cloud Transport Management.</a:t>
             </a:r>
             <a:endParaRPr lang="en-US" sz="1100" dirty="0"/>
           </a:p>
@@ -3176,7 +3176,7 @@
                 <a:ea typeface="Calibri" pitchFamily="34" charset="-122"/>
                 <a:cs typeface="Calibri" pitchFamily="34" charset="-120"/>
               </a:rPr>
-              <a:t>Severity ladder: notice (90d) → warn (30d) → critical (14d) → expired.</a:t>
+              <a:t>Filter by actor, action, resource type. Exportable for SOX/ISO/internal audit.</a:t>
             </a:r>
             <a:endParaRPr lang="en-US" sz="1100" dirty="0"/>
           </a:p>
@@ -3197,7 +3197,7 @@
                 <a:ea typeface="Calibri" pitchFamily="34" charset="-122"/>
                 <a:cs typeface="Calibri" pitchFamily="34" charset="-120"/>
               </a:rPr>
-              <a:t>Per-engagement rotation-owner registry maps cert patterns to named humans.</a:t>
+              <a:t>Anomaly detection: admin role granted outside change window, after-hours deploys.</a:t>
             </a:r>
             <a:endParaRPr lang="en-US" sz="1100" dirty="0"/>
           </a:p>
@@ -3218,7 +3218,7 @@
                 <a:ea typeface="Calibri" pitchFamily="34" charset="-122"/>
                 <a:cs typeface="Calibri" pitchFamily="34" charset="-120"/>
               </a:rPr>
-              <a:t>Acknowledge-until workflow suppresses noise during planned rotation windows.</a:t>
+              <a:t>Pairs naturally with app #1 — same Audit Log binding, different lens.</a:t>
             </a:r>
             <a:endParaRPr lang="en-US" sz="1100" dirty="0"/>
           </a:p>
@@ -3300,7 +3300,7 @@
                 <a:ea typeface="Calibri" pitchFamily="34" charset="-122"/>
                 <a:cs typeface="Calibri" pitchFamily="34" charset="-120"/>
               </a:rPr>
-              <a:t>Prevents the kind of incident that becomes a referral story.</a:t>
+              <a:t>Often the headline deliverable for compliance-driven engagements.</a:t>
             </a:r>
             <a:endParaRPr lang="en-US" sz="1100" dirty="0"/>
           </a:p>
@@ -3321,7 +3321,7 @@
                 <a:ea typeface="Calibri" pitchFamily="34" charset="-122"/>
                 <a:cs typeface="Calibri" pitchFamily="34" charset="-120"/>
               </a:rPr>
-              <a:t>Universally relevant — every BTP customer has an expiring cert they don't know about.</a:t>
+              <a:t>Customer's internal-audit team becomes a recurring stakeholder.</a:t>
             </a:r>
             <a:endParaRPr lang="en-US" sz="1100" dirty="0"/>
           </a:p>
@@ -3342,7 +3342,7 @@
                 <a:ea typeface="Calibri" pitchFamily="34" charset="-122"/>
                 <a:cs typeface="Calibri" pitchFamily="34" charset="-120"/>
               </a:rPr>
-              <a:t>Word-of-mouth multiplier: prevents one incident, sells the next three engagements.</a:t>
+              <a:t>Estimated build time: 1 week using shared srv/lib.</a:t>
             </a:r>
             <a:endParaRPr lang="en-US" sz="1100" dirty="0"/>
           </a:p>
@@ -3531,7 +3531,7 @@
                 <a:ea typeface="Georgia" pitchFamily="34" charset="-122"/>
                 <a:cs typeface="Georgia" pitchFamily="34" charset="-120"/>
               </a:rPr>
-              <a:t>APP 06</a:t>
+              <a:t>APP 07</a:t>
             </a:r>
             <a:endParaRPr lang="en-US" sz="1400" dirty="0"/>
           </a:p>
@@ -3570,7 +3570,7 @@
                 <a:ea typeface="Calibri" pitchFamily="34" charset="-122"/>
                 <a:cs typeface="Calibri" pitchFamily="34" charset="-120"/>
               </a:rPr>
-              <a:t>TIER 2 · COMPLIANCE-DRIVEN ENGAGEMENTS · IMPLEMENTED</a:t>
+              <a:t>TIER 2 · CFO-TIER ROI · IMPLEMENTED</a:t>
             </a:r>
             <a:endParaRPr lang="en-US" sz="1000" dirty="0"/>
           </a:p>
@@ -3609,7 +3609,7 @@
                 <a:ea typeface="Georgia" pitchFamily="34" charset="-122"/>
                 <a:cs typeface="Georgia" pitchFamily="34" charset="-120"/>
               </a:rPr>
-              <a:t>Audit-Log &amp; Change Inventory Console</a:t>
+              <a:t>Entitlement &amp; License Optimization Advisor</a:t>
             </a:r>
             <a:endParaRPr lang="en-US" sz="1800" dirty="0"/>
           </a:p>
@@ -3637,7 +3637,7 @@
       </p:sp>
       <p:pic>
         <p:nvPicPr>
-          <p:cNvPr id="8" name="Image 0" descr="D:\Claude\BTP Advisory APps\_pitch-deck\screenshots\app06-auditlog.png">    </p:cNvPr>
+          <p:cNvPr id="8" name="Image 0" descr="D:\Claude\BTP Advisory APps\_pitch-deck\screenshots\app07-entitlement.png">    </p:cNvPr>
           <p:cNvPicPr>
             <a:picLocks noChangeAspect="1"/>
           </p:cNvPicPr>
@@ -3691,7 +3691,7 @@
                 <a:ea typeface="Georgia" pitchFamily="34" charset="-122"/>
                 <a:cs typeface="Georgia" pitchFamily="34" charset="-120"/>
               </a:rPr>
-              <a:t>Unified change timeline across subaccounts. The deliverable a SOX walkthrough is built around.</a:t>
+              <a:t>Hard ROI for the renewal conversation. Gives procurement a number; gives you the next engagement.</a:t>
             </a:r>
             <a:endParaRPr lang="en-US" sz="1700" dirty="0"/>
           </a:p>
@@ -3773,7 +3773,7 @@
                 <a:ea typeface="Calibri" pitchFamily="34" charset="-122"/>
                 <a:cs typeface="Calibri" pitchFamily="34" charset="-120"/>
               </a:rPr>
-              <a:t>Aggregates Audit Log Retrieval Service + cTMS deployment history + Cloud Transport Management.</a:t>
+              <a:t>CIS Entitlements + UAS 12-24 month utilization history.</a:t>
             </a:r>
             <a:endParaRPr lang="en-US" sz="1100" dirty="0"/>
           </a:p>
@@ -3794,7 +3794,7 @@
                 <a:ea typeface="Calibri" pitchFamily="34" charset="-122"/>
                 <a:cs typeface="Calibri" pitchFamily="34" charset="-120"/>
               </a:rPr>
-              <a:t>Filter by actor, action, resource type. Exportable for SOX/ISO/internal audit.</a:t>
+              <a:t>"Approaching renewal" highlighting; downgrade recommendations with €/yr saving.</a:t>
             </a:r>
             <a:endParaRPr lang="en-US" sz="1100" dirty="0"/>
           </a:p>
@@ -3815,7 +3815,7 @@
                 <a:ea typeface="Calibri" pitchFamily="34" charset="-122"/>
                 <a:cs typeface="Calibri" pitchFamily="34" charset="-120"/>
               </a:rPr>
-              <a:t>Anomaly detection: admin role granted outside change window, after-hours deploys.</a:t>
+              <a:t>Different from BTPbilling: temporal not snapshot — sees the whole curve.</a:t>
             </a:r>
             <a:endParaRPr lang="en-US" sz="1100" dirty="0"/>
           </a:p>
@@ -3836,7 +3836,7 @@
                 <a:ea typeface="Calibri" pitchFamily="34" charset="-122"/>
                 <a:cs typeface="Calibri" pitchFamily="34" charset="-120"/>
               </a:rPr>
-              <a:t>Pairs naturally with app #1 — same Audit Log binding, different lens.</a:t>
+              <a:t>Direct extension of BTPbilling skeleton — fastest tier-2 build.</a:t>
             </a:r>
             <a:endParaRPr lang="en-US" sz="1100" dirty="0"/>
           </a:p>
@@ -3918,7 +3918,7 @@
                 <a:ea typeface="Calibri" pitchFamily="34" charset="-122"/>
                 <a:cs typeface="Calibri" pitchFamily="34" charset="-120"/>
               </a:rPr>
-              <a:t>Often the headline deliverable for compliance-driven engagements.</a:t>
+              <a:t>Procurement and CFO become economic buyers, not just IT.</a:t>
             </a:r>
             <a:endParaRPr lang="en-US" sz="1100" dirty="0"/>
           </a:p>
@@ -3939,7 +3939,7 @@
                 <a:ea typeface="Calibri" pitchFamily="34" charset="-122"/>
                 <a:cs typeface="Calibri" pitchFamily="34" charset="-120"/>
               </a:rPr>
-              <a:t>Customer's internal-audit team becomes a recurring stakeholder.</a:t>
+              <a:t>Typical finding: €X00K/yr in headroom optimization.</a:t>
             </a:r>
             <a:endParaRPr lang="en-US" sz="1100" dirty="0"/>
           </a:p>
@@ -3960,7 +3960,7 @@
                 <a:ea typeface="Calibri" pitchFamily="34" charset="-122"/>
                 <a:cs typeface="Calibri" pitchFamily="34" charset="-120"/>
               </a:rPr>
-              <a:t>Estimated build time: 1 week using shared srv/lib.</a:t>
+              <a:t>Engagement self-funds inside one renewal cycle.</a:t>
             </a:r>
             <a:endParaRPr lang="en-US" sz="1100" dirty="0"/>
           </a:p>
@@ -4149,7 +4149,7 @@
                 <a:ea typeface="Georgia" pitchFamily="34" charset="-122"/>
                 <a:cs typeface="Georgia" pitchFamily="34" charset="-120"/>
               </a:rPr>
-              <a:t>APP 07</a:t>
+              <a:t>APP 08</a:t>
             </a:r>
             <a:endParaRPr lang="en-US" sz="1400" dirty="0"/>
           </a:p>
@@ -4188,7 +4188,7 @@
                 <a:ea typeface="Calibri" pitchFamily="34" charset="-122"/>
                 <a:cs typeface="Calibri" pitchFamily="34" charset="-120"/>
               </a:rPr>
-              <a:t>TIER 2 · CFO-TIER ROI · IMPLEMENTED</a:t>
+              <a:t>TIER 3 · 2026 CISO BUDGET · IMPLEMENTED</a:t>
             </a:r>
             <a:endParaRPr lang="en-US" sz="1000" dirty="0"/>
           </a:p>
@@ -4227,7 +4227,7 @@
                 <a:ea typeface="Georgia" pitchFamily="34" charset="-122"/>
                 <a:cs typeface="Georgia" pitchFamily="34" charset="-120"/>
               </a:rPr>
-              <a:t>Entitlement &amp; License Optimization Advisor</a:t>
+              <a:t>BTP AI Services Governance Console</a:t>
             </a:r>
             <a:endParaRPr lang="en-US" sz="1800" dirty="0"/>
           </a:p>
@@ -4255,7 +4255,7 @@
       </p:sp>
       <p:pic>
         <p:nvPicPr>
-          <p:cNvPr id="8" name="Image 0" descr="D:\Claude\BTP Advisory APps\_pitch-deck\screenshots\app07-entitlement.png">    </p:cNvPr>
+          <p:cNvPr id="8" name="Image 0" descr="D:\Claude\BTP Advisory APps\_pitch-deck\screenshots\app08-aigovernance.png">    </p:cNvPr>
           <p:cNvPicPr>
             <a:picLocks noChangeAspect="1"/>
           </p:cNvPicPr>
@@ -4309,7 +4309,7 @@
                 <a:ea typeface="Georgia" pitchFamily="34" charset="-122"/>
                 <a:cs typeface="Georgia" pitchFamily="34" charset="-120"/>
               </a:rPr>
-              <a:t>Hard ROI for the renewal conversation. Gives procurement a number; gives you the next engagement.</a:t>
+              <a:t>"What are people actually doing with GenAI?" — the question every CISO is being asked in board meetings.</a:t>
             </a:r>
             <a:endParaRPr lang="en-US" sz="1700" dirty="0"/>
           </a:p>
@@ -4391,7 +4391,7 @@
                 <a:ea typeface="Calibri" pitchFamily="34" charset="-122"/>
                 <a:cs typeface="Calibri" pitchFamily="34" charset="-120"/>
               </a:rPr>
-              <a:t>CIS Entitlements + UAS 12-24 month utilization history.</a:t>
+              <a:t>Generative AI Hub orchestration prompts deployed where, by whom.</a:t>
             </a:r>
             <a:endParaRPr lang="en-US" sz="1100" dirty="0"/>
           </a:p>
@@ -4412,7 +4412,7 @@
                 <a:ea typeface="Calibri" pitchFamily="34" charset="-122"/>
                 <a:cs typeface="Calibri" pitchFamily="34" charset="-120"/>
               </a:rPr>
-              <a:t>"Approaching renewal" highlighting; downgrade recommendations with €/yr saving.</a:t>
+              <a:t>Model spend by subaccount/team/cost-center.</a:t>
             </a:r>
             <a:endParaRPr lang="en-US" sz="1100" dirty="0"/>
           </a:p>
@@ -4433,7 +4433,7 @@
                 <a:ea typeface="Calibri" pitchFamily="34" charset="-122"/>
                 <a:cs typeface="Calibri" pitchFamily="34" charset="-120"/>
               </a:rPr>
-              <a:t>Different from BTPbilling: temporal not snapshot — sees the whole curve.</a:t>
+              <a:t>Content-filter &amp; data-masking config per scenario.</a:t>
             </a:r>
             <a:endParaRPr lang="en-US" sz="1100" dirty="0"/>
           </a:p>
@@ -4454,7 +4454,7 @@
                 <a:ea typeface="Calibri" pitchFamily="34" charset="-122"/>
                 <a:cs typeface="Calibri" pitchFamily="34" charset="-120"/>
               </a:rPr>
-              <a:t>Direct extension of BTPbilling skeleton — fastest tier-2 build.</a:t>
+              <a:t>Prompt-injection alerts; prohibited-data egress detection.</a:t>
             </a:r>
             <a:endParaRPr lang="en-US" sz="1100" dirty="0"/>
           </a:p>
@@ -4536,7 +4536,7 @@
                 <a:ea typeface="Calibri" pitchFamily="34" charset="-122"/>
                 <a:cs typeface="Calibri" pitchFamily="34" charset="-120"/>
               </a:rPr>
-              <a:t>Procurement and CFO become economic buyers, not just IT.</a:t>
+              <a:t>Credibility wedge for AI-curious CIOs with fresh budget.</a:t>
             </a:r>
             <a:endParaRPr lang="en-US" sz="1100" dirty="0"/>
           </a:p>
@@ -4557,7 +4557,7 @@
                 <a:ea typeface="Calibri" pitchFamily="34" charset="-122"/>
                 <a:cs typeface="Calibri" pitchFamily="34" charset="-120"/>
               </a:rPr>
-              <a:t>Typical finding: €X00K/yr in headroom optimization.</a:t>
+              <a:t>Pairs with the AI swarm offering for full-stack AI governance.</a:t>
             </a:r>
             <a:endParaRPr lang="en-US" sz="1100" dirty="0"/>
           </a:p>
@@ -4578,7 +4578,7 @@
                 <a:ea typeface="Calibri" pitchFamily="34" charset="-122"/>
                 <a:cs typeface="Calibri" pitchFamily="34" charset="-120"/>
               </a:rPr>
-              <a:t>Engagement self-funds inside one renewal cycle.</a:t>
+              <a:t>Higher engineering risk: AI Core APIs still maturing — built when an engagement specifically scopes it.</a:t>
             </a:r>
             <a:endParaRPr lang="en-US" sz="1100" dirty="0"/>
           </a:p>
@@ -4767,7 +4767,7 @@
                 <a:ea typeface="Georgia" pitchFamily="34" charset="-122"/>
                 <a:cs typeface="Georgia" pitchFamily="34" charset="-120"/>
               </a:rPr>
-              <a:t>APP 08</a:t>
+              <a:t>APP 09</a:t>
             </a:r>
             <a:endParaRPr lang="en-US" sz="1400" dirty="0"/>
           </a:p>
@@ -4806,7 +4806,7 @@
                 <a:ea typeface="Calibri" pitchFamily="34" charset="-122"/>
                 <a:cs typeface="Calibri" pitchFamily="34" charset="-120"/>
               </a:rPr>
-              <a:t>TIER 3 · 2026 CISO BUDGET · IMPLEMENTED</a:t>
+              <a:t>TIER 3 · INCIDENT PREVENTION · IMPLEMENTED</a:t>
             </a:r>
             <a:endParaRPr lang="en-US" sz="1000" dirty="0"/>
           </a:p>
@@ -4845,7 +4845,7 @@
                 <a:ea typeface="Georgia" pitchFamily="34" charset="-122"/>
                 <a:cs typeface="Georgia" pitchFamily="34" charset="-120"/>
               </a:rPr>
-              <a:t>BTP AI Services Governance Console</a:t>
+              <a:t>Trust Config &amp; Cert Expiry Console</a:t>
             </a:r>
             <a:endParaRPr lang="en-US" sz="1800" dirty="0"/>
           </a:p>
@@ -4873,7 +4873,7 @@
       </p:sp>
       <p:pic>
         <p:nvPicPr>
-          <p:cNvPr id="8" name="Image 0" descr="D:\Claude\BTP Advisory APps\_pitch-deck\screenshots\app08-aigovernance.png">    </p:cNvPr>
+          <p:cNvPr id="8" name="Image 0" descr="D:\Claude\BTP Advisory APps\_pitch-deck\screenshots\app09-certs.png">    </p:cNvPr>
           <p:cNvPicPr>
             <a:picLocks noChangeAspect="1"/>
           </p:cNvPicPr>
@@ -4927,7 +4927,7 @@
                 <a:ea typeface="Georgia" pitchFamily="34" charset="-122"/>
                 <a:cs typeface="Georgia" pitchFamily="34" charset="-120"/>
               </a:rPr>
-              <a:t>"What are people actually doing with GenAI?" — the question every CISO is being asked in board meetings.</a:t>
+              <a:t>Every certificate across the BTP landscape with rotation owner, blast radius, and acknowledgement workflow.</a:t>
             </a:r>
             <a:endParaRPr lang="en-US" sz="1700" dirty="0"/>
           </a:p>
@@ -5009,7 +5009,7 @@
                 <a:ea typeface="Calibri" pitchFamily="34" charset="-122"/>
                 <a:cs typeface="Calibri" pitchFamily="34" charset="-120"/>
               </a:rPr>
-              <a:t>Generative AI Hub orchestration prompts deployed where, by whom.</a:t>
+              <a:t>Aggregates from destinations, IAS SAML/OIDC, XSUAA trust configs, cTMS keys.</a:t>
             </a:r>
             <a:endParaRPr lang="en-US" sz="1100" dirty="0"/>
           </a:p>
@@ -5030,7 +5030,7 @@
                 <a:ea typeface="Calibri" pitchFamily="34" charset="-122"/>
                 <a:cs typeface="Calibri" pitchFamily="34" charset="-120"/>
               </a:rPr>
-              <a:t>Model spend by subaccount/team/cost-center.</a:t>
+              <a:t>Severity ladder: notice (90d) → warn (30d) → critical (14d) → expired.</a:t>
             </a:r>
             <a:endParaRPr lang="en-US" sz="1100" dirty="0"/>
           </a:p>
@@ -5051,7 +5051,7 @@
                 <a:ea typeface="Calibri" pitchFamily="34" charset="-122"/>
                 <a:cs typeface="Calibri" pitchFamily="34" charset="-120"/>
               </a:rPr>
-              <a:t>Content-filter &amp; data-masking config per scenario.</a:t>
+              <a:t>Per-engagement rotation-owner registry maps cert patterns to named humans.</a:t>
             </a:r>
             <a:endParaRPr lang="en-US" sz="1100" dirty="0"/>
           </a:p>
@@ -5072,7 +5072,7 @@
                 <a:ea typeface="Calibri" pitchFamily="34" charset="-122"/>
                 <a:cs typeface="Calibri" pitchFamily="34" charset="-120"/>
               </a:rPr>
-              <a:t>Prompt-injection alerts; prohibited-data egress detection.</a:t>
+              <a:t>Acknowledge-until workflow suppresses noise during planned rotation windows.</a:t>
             </a:r>
             <a:endParaRPr lang="en-US" sz="1100" dirty="0"/>
           </a:p>
@@ -5154,7 +5154,7 @@
                 <a:ea typeface="Calibri" pitchFamily="34" charset="-122"/>
                 <a:cs typeface="Calibri" pitchFamily="34" charset="-120"/>
               </a:rPr>
-              <a:t>Credibility wedge for AI-curious CIOs with fresh budget.</a:t>
+              <a:t>Prevents the kind of incident that becomes a referral story.</a:t>
             </a:r>
             <a:endParaRPr lang="en-US" sz="1100" dirty="0"/>
           </a:p>
@@ -5175,7 +5175,7 @@
                 <a:ea typeface="Calibri" pitchFamily="34" charset="-122"/>
                 <a:cs typeface="Calibri" pitchFamily="34" charset="-120"/>
               </a:rPr>
-              <a:t>Pairs with the AI swarm offering for full-stack AI governance.</a:t>
+              <a:t>Universally relevant — every BTP customer has an expiring cert they don't know about.</a:t>
             </a:r>
             <a:endParaRPr lang="en-US" sz="1100" dirty="0"/>
           </a:p>
@@ -5196,7 +5196,7 @@
                 <a:ea typeface="Calibri" pitchFamily="34" charset="-122"/>
                 <a:cs typeface="Calibri" pitchFamily="34" charset="-120"/>
               </a:rPr>
-              <a:t>Higher engineering risk: AI Core APIs still maturing — built when an engagement specifically scopes it.</a:t>
+              <a:t>Word-of-mouth multiplier: prevents one incident, sells the next three engagements.</a:t>
             </a:r>
             <a:endParaRPr lang="en-US" sz="1100" dirty="0"/>
           </a:p>

</xml_diff>